<commit_message>
Update slides: add GitHub repo link, tool versions, actual demo output in speaker notes
</commit_message>
<xml_diff>
--- a/MCP_Live_Streaming_Context.pptx
+++ b/MCP_Live_Streaming_Context.pptx
@@ -818,17 +818,17 @@
           </a:p>
           <a:p>
             <a:r>
-              <a:t>- Thank you for your time. The complete working code is in the mcp-streaming-demo repo.</a:t>
-            </a:r>
-          </a:p>
-          <a:p>
-            <a:r>
-              <a:t>- Everything is open source: Kafka, Cedar, WebSockets, and all the Python code.</a:t>
-            </a:r>
-          </a:p>
-          <a:p>
-            <a:r>
-              <a:t>- To run the demo yourself: docker-compose up for Kafka, then run the streaming MCP server, log simulator, and agent client.</a:t>
+              <a:t>- Thank you for your time. The complete working code is on GitHub: github.com/hakohli/mcp-streaming-demo</a:t>
+            </a:r>
+          </a:p>
+          <a:p>
+            <a:r>
+              <a:t>- Everything is open source: Confluent Kafka 7.6.0, Cedar, WebSockets 15.0.1, Python 3.9+.</a:t>
+            </a:r>
+          </a:p>
+          <a:p>
+            <a:r>
+              <a:t>- To run the demo yourself: docker compose up -d for Kafka, then run streaming_mcp_server.py, log_simulator.py, and agent_client.py.</a:t>
             </a:r>
           </a:p>
           <a:p>
@@ -1408,7 +1408,12 @@
           </a:p>
           <a:p>
             <a:r>
-              <a:t>- Time for the live demo. Here's what's running: a log simulator generates realistic application logs and pushes them to Kafka. The streaming MCP server consumes from Kafka and pushes to connected agents.</a:t>
+              <a:t>- Time for the live demo. Stack: Confluent Kafka 7.6.0 in Docker, Python 3.9, confluent-kafka 2.13.2, websockets 15.0.1.</a:t>
+            </a:r>
+          </a:p>
+          <a:p>
+            <a:r>
+              <a:t>- Here's what's running: a log simulator generates realistic application logs and pushes them to Kafka. The streaming MCP server consumes from Kafka and pushes to connected agents.</a:t>
             </a:r>
           </a:p>
           <a:p>
@@ -1423,12 +1428,12 @@
           </a:p>
           <a:p>
             <a:r>
-              <a:t>- Watch the agent: within 1 second of the error spike, it detects the anomaly. It then queries the server for a structured anomaly summary — this is the hybrid protocol in action.</a:t>
-            </a:r>
-          </a:p>
-          <a:p>
-            <a:r>
-              <a:t>- The agent automatically maps error patterns to fix suggestions: 'ConnectionError → restart service', 'OutOfMemoryError → increase heap size'.</a:t>
+              <a:t>- Watch the agent: it detected '🚨 ANOMALY DETECTED — error rate 60% in last 20 events' — within 1 second of the spike.</a:t>
+            </a:r>
+          </a:p>
+          <a:p>
+            <a:r>
+              <a:t>- The agent automatically suggested fixes: ConnectionRefused → check service status; OutOfMemoryError → increase JVM heap; Timeout → add circuit breaker; Deadlock → review transaction isolation.</a:t>
             </a:r>
           </a:p>
           <a:p>
@@ -4730,6 +4735,10 @@
             <a:r>
               <a:t>Building Reactive MCP Servers with Kafka, WebSockets &amp; Cedar</a:t>
             </a:r>
+            <a:br/>
+            <a:r>
+              <a:t>github.com/hakohli/mcp-streaming-demo</a:t>
+            </a:r>
           </a:p>
         </p:txBody>
       </p:sp>
@@ -5034,7 +5043,7 @@
               </a:defRPr>
             </a:pPr>
             <a:r>
-              <a:t>Kafka + WebSocket = durable, scalable streaming bridge</a:t>
+              <a:t>Kafka (Confluent 7.6.0) + WebSocket = durable, scalable streaming bridge</a:t>
             </a:r>
           </a:p>
           <a:p>
@@ -5050,7 +5059,7 @@
               </a:defRPr>
             </a:pPr>
             <a:r>
-              <a:t>Cedar provides declarative, auditable authorization</a:t>
+              <a:t>Cedar provides declarative, auditable authorization for MCP</a:t>
             </a:r>
           </a:p>
           <a:p>
@@ -5067,6 +5076,22 @@
             </a:pPr>
             <a:r>
               <a:t>Hybrid protocol (push + pull) on single connection is the sweet spot</a:t>
+            </a:r>
+          </a:p>
+          <a:p>
+            <a:pPr>
+              <a:spcAft>
+                <a:spcPts val="800"/>
+              </a:spcAft>
+              <a:defRPr sz="1800">
+                <a:solidFill>
+                  <a:srgbClr val="FFFFFF"/>
+                </a:solidFill>
+                <a:latin typeface="Calibri"/>
+              </a:defRPr>
+            </a:pPr>
+            <a:r>
+              <a:t>All open source — Python 3.9+, Docker, ~200 lines of code</a:t>
             </a:r>
           </a:p>
         </p:txBody>
@@ -5188,11 +5213,11 @@
               </a:defRPr>
             </a:pPr>
             <a:r>
-              <a:t>Code: ~/mcp-streaming-demo</a:t>
+              <a:t>github.com/hakohli/mcp-streaming-demo</a:t>
             </a:r>
             <a:br/>
             <a:r>
-              <a:t>All open source: Kafka · Cedar · WebSockets</a:t>
+              <a:t>All open source: Kafka · Cedar · WebSockets · Python</a:t>
             </a:r>
           </a:p>
         </p:txBody>

</xml_diff>

<commit_message>
Add detailed System Architecture slide with full component diagram and speaker notes
</commit_message>
<xml_diff>
--- a/MCP_Live_Streaming_Context.pptx
+++ b/MCP_Live_Streaming_Context.pptx
@@ -17,6 +17,7 @@
     <p:sldId id="265" r:id="rId17"/>
     <p:sldId id="266" r:id="rId18"/>
     <p:sldId id="267" r:id="rId19"/>
+    <p:sldId id="268" r:id="rId20"/>
   </p:sldIdLst>
   <p:sldSz cx="12191695" cy="6858000" type="screen4x3"/>
   <p:notesSz cx="6858000" cy="9144000"/>
@@ -613,37 +614,32 @@
           </a:p>
           <a:p>
             <a:r>
-              <a:t>- This pattern isn't just for log monitoring. Once you have streaming MCP, a whole category of use cases opens up.</a:t>
-            </a:r>
-          </a:p>
-          <a:p>
-            <a:r>
-              <a:t>- DevOps is the obvious one — what we demoed today. Real-time incident detection, automated triage, and remediation suggestions. Imagine on-call agents that never sleep.</a:t>
-            </a:r>
-          </a:p>
-          <a:p>
-            <a:r>
-              <a:t>- Trading: feed live market data — price ticks, order book changes, news events — directly to AI decision agents. Latency matters here; polling is not an option.</a:t>
-            </a:r>
-          </a:p>
-          <a:p>
-            <a:r>
-              <a:t>- Security: stream audit logs to compliance agents with Cedar controlling who sees what. Your SOC agent gets real-time alerts; your readonly dashboard agent gets summaries only.</a:t>
-            </a:r>
-          </a:p>
-          <a:p>
-            <a:r>
-              <a:t>- CI/CD: file watchers that notify agents when code changes. Agent sees a PR merged, automatically runs tests, checks for security issues, updates documentation.</a:t>
-            </a:r>
-          </a:p>
-          <a:p>
-            <a:r>
-              <a:t>- IoT: sensor data from factory floors, vehicles, or infrastructure streaming to predictive maintenance agents. Detect anomalies before equipment fails.</a:t>
-            </a:r>
-          </a:p>
-          <a:p>
-            <a:r>
-              <a:t>- The common thread: any domain where waiting to be asked is too slow.</a:t>
+              <a:t>- These are the lessons learned from building this. Things that will bite you in production.</a:t>
+            </a:r>
+          </a:p>
+          <a:p>
+            <a:r>
+              <a:t>- Backpressure is #1 for a reason. If an agent can't keep up with the event stream, you need bounded queues. Our implementation uses a 500-event asyncio queue per subscriber. When full, oldest events are dropped. You could also use dead-letter topics in Kafka for events that couldn't be delivered.</a:t>
+            </a:r>
+          </a:p>
+          <a:p>
+            <a:r>
+              <a:t>- The hybrid protocol is the sweet spot. Don't force everything into streaming OR request/response. Let agents subscribe to live feeds for continuous monitoring, but also query on-demand for summaries and context. Same WebSocket, same connection.</a:t>
+            </a:r>
+          </a:p>
+          <a:p>
+            <a:r>
+              <a:t>- Kafka consumer groups are powerful but confusing. Same group ID = events are load-balanced across consumers (each event goes to ONE consumer). Different group IDs = fan-out (each event goes to ALL consumers). Choose based on your use case.</a:t>
+            </a:r>
+          </a:p>
+          <a:p>
+            <a:r>
+              <a:t>- Reconnection strategy matters. Use exponential backoff to avoid thundering herd. On reconnect, send a context snapshot so the agent doesn't start from zero.</a:t>
+            </a:r>
+          </a:p>
+          <a:p>
+            <a:r>
+              <a:t>- Be selective about what you stream. Errors and anomalies? Stream them. Normal INFO-level metrics? Batch those and let agents poll. Don't flood the pipe with noise.</a:t>
             </a:r>
           </a:p>
         </p:txBody>
@@ -718,32 +714,37 @@
           </a:p>
           <a:p>
             <a:r>
-              <a:t>- Four things to remember from this talk.</a:t>
-            </a:r>
-          </a:p>
-          <a:p>
-            <a:r>
-              <a:t>- First: MCP is extensible. The spec doesn't limit you to request/response. Streaming is a natural extension that the protocol can support.</a:t>
-            </a:r>
-          </a:p>
-          <a:p>
-            <a:r>
-              <a:t>- Second: you don't need exotic infrastructure. Kafka gives you durable, replayable event streaming. WebSockets give you real-time push. Both are battle-tested, widely deployed, and well-understood.</a:t>
-            </a:r>
-          </a:p>
-          <a:p>
-            <a:r>
-              <a:t>- Third: authorization is not optional. Cedar gives you declarative, auditable policies that your security team can review. Default deny means you start secure and open up access explicitly.</a:t>
-            </a:r>
-          </a:p>
-          <a:p>
-            <a:r>
-              <a:t>- Fourth: the hybrid protocol is the key design decision. Don't choose between streaming and request/response — do both on the same connection. Agents get the best of both worlds.</a:t>
-            </a:r>
-          </a:p>
-          <a:p>
-            <a:r>
-              <a:t>- The diagram shows how these three pieces converge into the streaming MCP server. Each solves a different problem; together they create something powerful.</a:t>
+              <a:t>- This pattern isn't just for log monitoring. Once you have streaming MCP, a whole category of use cases opens up.</a:t>
+            </a:r>
+          </a:p>
+          <a:p>
+            <a:r>
+              <a:t>- DevOps is the obvious one — what we demoed today. Real-time incident detection, automated triage, and remediation suggestions. Imagine on-call agents that never sleep.</a:t>
+            </a:r>
+          </a:p>
+          <a:p>
+            <a:r>
+              <a:t>- Trading: feed live market data — price ticks, order book changes, news events — directly to AI decision agents. Latency matters here; polling is not an option.</a:t>
+            </a:r>
+          </a:p>
+          <a:p>
+            <a:r>
+              <a:t>- Security: stream audit logs to compliance agents with Cedar controlling who sees what. Your SOC agent gets real-time alerts; your readonly dashboard agent gets summaries only.</a:t>
+            </a:r>
+          </a:p>
+          <a:p>
+            <a:r>
+              <a:t>- CI/CD: file watchers that notify agents when code changes. Agent sees a PR merged, automatically runs tests, checks for security issues, updates documentation.</a:t>
+            </a:r>
+          </a:p>
+          <a:p>
+            <a:r>
+              <a:t>- IoT: sensor data from factory floors, vehicles, or infrastructure streaming to predictive maintenance agents. Detect anomalies before equipment fails.</a:t>
+            </a:r>
+          </a:p>
+          <a:p>
+            <a:r>
+              <a:t>- The common thread: any domain where waiting to be asked is too slow.</a:t>
             </a:r>
           </a:p>
         </p:txBody>
@@ -818,6 +819,106 @@
           </a:p>
           <a:p>
             <a:r>
+              <a:t>- Four things to remember from this talk.</a:t>
+            </a:r>
+          </a:p>
+          <a:p>
+            <a:r>
+              <a:t>- First: MCP is extensible. The spec doesn't limit you to request/response. Streaming is a natural extension that the protocol can support.</a:t>
+            </a:r>
+          </a:p>
+          <a:p>
+            <a:r>
+              <a:t>- Second: you don't need exotic infrastructure. Kafka gives you durable, replayable event streaming. WebSockets give you real-time push. Both are battle-tested, widely deployed, and well-understood.</a:t>
+            </a:r>
+          </a:p>
+          <a:p>
+            <a:r>
+              <a:t>- Third: authorization is not optional. Cedar gives you declarative, auditable policies that your security team can review. Default deny means you start secure and open up access explicitly.</a:t>
+            </a:r>
+          </a:p>
+          <a:p>
+            <a:r>
+              <a:t>- Fourth: the hybrid protocol is the key design decision. Don't choose between streaming and request/response — do both on the same connection. Agents get the best of both worlds.</a:t>
+            </a:r>
+          </a:p>
+          <a:p>
+            <a:r>
+              <a:t>- The diagram shows how these three pieces converge into the streaming MCP server. Each solves a different problem; together they create something powerful.</a:t>
+            </a:r>
+          </a:p>
+        </p:txBody>
+      </p:sp>
+      <p:sp>
+        <p:nvSpPr>
+          <p:cNvPr id="4" name="Slide Number Placeholder 3"/>
+          <p:cNvSpPr>
+            <a:spLocks noGrp="1"/>
+          </p:cNvSpPr>
+          <p:nvPr>
+            <p:ph type="sldNum" idx="5" sz="quarter"/>
+          </p:nvPr>
+        </p:nvSpPr>
+        <p:spPr/>
+      </p:sp>
+    </p:spTree>
+  </p:cSld>
+  <p:clrMapOvr>
+    <a:masterClrMapping/>
+  </p:clrMapOvr>
+</p:notes>
+</file>
+
+<file path=ppt/notesSlides/notesSlide13.xml><?xml version="1.0" encoding="utf-8"?>
+<p:notes xmlns:a="http://schemas.openxmlformats.org/drawingml/2006/main" xmlns:p="http://schemas.openxmlformats.org/presentationml/2006/main" xmlns:r="http://schemas.openxmlformats.org/officeDocument/2006/relationships">
+  <p:cSld>
+    <p:spTree>
+      <p:nvGrpSpPr>
+        <p:cNvPr id="1" name=""/>
+        <p:cNvGrpSpPr/>
+        <p:nvPr/>
+      </p:nvGrpSpPr>
+      <p:grpSpPr>
+        <a:xfrm>
+          <a:off x="0" y="0"/>
+          <a:ext cx="0" cy="0"/>
+          <a:chOff x="0" y="0"/>
+          <a:chExt cx="0" cy="0"/>
+        </a:xfrm>
+      </p:grpSpPr>
+      <p:sp>
+        <p:nvSpPr>
+          <p:cNvPr id="2" name="Slide Image Placeholder 1"/>
+          <p:cNvSpPr>
+            <a:spLocks noGrp="1"/>
+          </p:cNvSpPr>
+          <p:nvPr>
+            <p:ph type="sldImg" idx="2"/>
+          </p:nvPr>
+        </p:nvSpPr>
+        <p:spPr/>
+      </p:sp>
+      <p:sp>
+        <p:nvSpPr>
+          <p:cNvPr id="3" name="Notes Placeholder 2"/>
+          <p:cNvSpPr>
+            <a:spLocks noGrp="1"/>
+          </p:cNvSpPr>
+          <p:nvPr>
+            <p:ph type="body" idx="3" sz="quarter"/>
+          </p:nvPr>
+        </p:nvSpPr>
+        <p:spPr/>
+        <p:txBody>
+          <a:bodyPr/>
+          <a:lstStyle/>
+          <a:p>
+            <a:r>
+              <a:t>TALKING POINTS:</a:t>
+            </a:r>
+          </a:p>
+          <a:p>
+            <a:r>
               <a:t>- Thank you for your time. The complete working code is on GitHub: github.com/hakohli/mcp-streaming-demo</a:t>
             </a:r>
           </a:p>
@@ -913,32 +1014,57 @@
           </a:p>
           <a:p>
             <a:r>
-              <a:t>- Let's start with the problem. Today, MCP works like a snapshot camera — the agent asks a question, gets a point-in-time answer, and moves on.</a:t>
-            </a:r>
-          </a:p>
-          <a:p>
-            <a:r>
-              <a:t>- Imagine this real scenario: you deploy at 2:03pm. Errors start spiking at 2:04pm. But your agent doesn't poll again until 2:15pm. That's an 11-minute blind spot where your production system is on fire and nobody knows.</a:t>
-            </a:r>
-          </a:p>
-          <a:p>
-            <a:r>
-              <a:t>- The diagram on the right shows this timeline visually — the red gap is the danger zone.</a:t>
-            </a:r>
-          </a:p>
-          <a:p>
-            <a:r>
-              <a:t>- In fast-moving environments — incident response, trading, security — 11 minutes is an eternity.</a:t>
-            </a:r>
-          </a:p>
-          <a:p>
-            <a:r>
-              <a:t>- The fundamental question: can we flip the model so context flows TO the agent continuously, rather than the agent having to ask for it?</a:t>
-            </a:r>
-          </a:p>
-          <a:p>
-            <a:r>
-              <a:t>- Spoiler: yes, and it's not as hard as you'd think.</a:t>
+              <a:t>- This is the full system architecture. Let me walk through each component.</a:t>
+            </a:r>
+          </a:p>
+          <a:p>
+            <a:r>
+              <a:t>- Starting on the left: the Log Simulator generates realistic application logs — INFO, WARN, ERROR, FATAL — from five simulated services: api-gateway, auth-service, payment-service, order-service, and inventory-db. Every ~30 seconds it triggers an error spike.</a:t>
+            </a:r>
+          </a:p>
+          <a:p>
+            <a:r>
+              <a:t>- Events flow into Apache Kafka (Confluent 7.6.0, running in KRaft mode via Docker). Kafka gives us durability, replayability, and decoupling between producers and consumers.</a:t>
+            </a:r>
+          </a:p>
+          <a:p>
+            <a:r>
+              <a:t>- The Streaming MCP Server is the core — it has four sub-components:</a:t>
+            </a:r>
+          </a:p>
+          <a:p>
+            <a:r>
+              <a:t>  1. Kafka Consumer: pulls events and maintains a rolling 100-event window for analysis.</a:t>
+            </a:r>
+          </a:p>
+          <a:p>
+            <a:r>
+              <a:t>  2. Anomaly Detection: tracks error counts by pattern (ConnectionRefused, OOM, Timeout, etc.) across the window.</a:t>
+            </a:r>
+          </a:p>
+          <a:p>
+            <a:r>
+              <a:t>  3. WebSocket Server on port 8765: pushes live events to all subscribed agents. Each subscriber gets a bounded 500-event queue — if they fall behind, oldest events are dropped.</a:t>
+            </a:r>
+          </a:p>
+          <a:p>
+            <a:r>
+              <a:t>  4. Cedar Policy Engine: evaluates every agent request against declarative permit/forbid policies. Default deny — no matching policy means the request is blocked.</a:t>
+            </a:r>
+          </a:p>
+          <a:p>
+            <a:r>
+              <a:t>- On the right: the AI Agent. It subscribes once and receives a continuous stream. It runs a 20-event sliding window — when error rate exceeds 30%, it flags an anomaly. It can also send get_anomalies() back to the server for a structured summary — that's the hybrid protocol, push AND pull on the same WebSocket.</a:t>
+            </a:r>
+          </a:p>
+          <a:p>
+            <a:r>
+              <a:t>- The Remediation Engine maps known error patterns to actionable fixes: ConnectionRefused → check service status; OOM → increase heap; Timeout → circuit breaker; Deadlock → review isolation levels.</a:t>
+            </a:r>
+          </a:p>
+          <a:p>
+            <a:r>
+              <a:t>- Notice the two arrow colors: teal for streaming push, blue for request/response pull. Both coexist on the same connection. This is the key design insight.</a:t>
             </a:r>
           </a:p>
         </p:txBody>
@@ -1013,27 +1139,32 @@
           </a:p>
           <a:p>
             <a:r>
-              <a:t>- Here's the architecture side by side. Top row is traditional MCP — pull-based, request/response.</a:t>
-            </a:r>
-          </a:p>
-          <a:p>
-            <a:r>
-              <a:t>- Bottom row is what we're building: event sources feed into Kafka, Kafka feeds the MCP server, and the server pushes to agents over WebSockets.</a:t>
-            </a:r>
-          </a:p>
-          <a:p>
-            <a:r>
-              <a:t>- Why Kafka specifically? Three reasons: (1) durability — events are persisted, so if an agent disconnects and reconnects, it can replay what it missed. (2) Backpressure — Kafka handles slow consumers gracefully via consumer groups and offsets. (3) It's probably already in your infrastructure.</a:t>
-            </a:r>
-          </a:p>
-          <a:p>
-            <a:r>
-              <a:t>- The key insight is the hybrid protocol — we keep standard request/response for on-demand queries, but ADD streaming on the same WebSocket connection. The agent can subscribe to a live feed AND still ask ad-hoc questions.</a:t>
-            </a:r>
-          </a:p>
-          <a:p>
-            <a:r>
-              <a:t>- This means zero changes to existing MCP tools — we're extending, not replacing.</a:t>
+              <a:t>- Let's start with the problem. Today, MCP works like a snapshot camera — the agent asks a question, gets a point-in-time answer, and moves on.</a:t>
+            </a:r>
+          </a:p>
+          <a:p>
+            <a:r>
+              <a:t>- Imagine this real scenario: you deploy at 2:03pm. Errors start spiking at 2:04pm. But your agent doesn't poll again until 2:15pm. That's an 11-minute blind spot where your production system is on fire and nobody knows.</a:t>
+            </a:r>
+          </a:p>
+          <a:p>
+            <a:r>
+              <a:t>- The diagram on the right shows this timeline visually — the red gap is the danger zone.</a:t>
+            </a:r>
+          </a:p>
+          <a:p>
+            <a:r>
+              <a:t>- In fast-moving environments — incident response, trading, security — 11 minutes is an eternity.</a:t>
+            </a:r>
+          </a:p>
+          <a:p>
+            <a:r>
+              <a:t>- The fundamental question: can we flip the model so context flows TO the agent continuously, rather than the agent having to ask for it?</a:t>
+            </a:r>
+          </a:p>
+          <a:p>
+            <a:r>
+              <a:t>- Spoiler: yes, and it's not as hard as you'd think.</a:t>
             </a:r>
           </a:p>
         </p:txBody>
@@ -1108,32 +1239,27 @@
           </a:p>
           <a:p>
             <a:r>
-              <a:t>- The protocol extension is minimal — we add just two new methods: subscribe and unsubscribe.</a:t>
-            </a:r>
-          </a:p>
-          <a:p>
-            <a:r>
-              <a:t>- Walk through the sequence diagram: Agent sends subscribe('app-logs'). Server starts pushing events as they arrive from Kafka. Normal log entries flow through. Then an error spike hits — the agent sees it immediately.</a:t>
-            </a:r>
-          </a:p>
-          <a:p>
-            <a:r>
-              <a:t>- Here's the hybrid part: mid-stream, the agent sends get_anomalies() — a standard request/response call — and gets back a structured anomaly summary. Both protocols coexist on the same WebSocket.</a:t>
-            </a:r>
-          </a:p>
-          <a:p>
-            <a:r>
-              <a:t>- When the agent is done, it sends unsubscribe to clean up.</a:t>
-            </a:r>
-          </a:p>
-          <a:p>
-            <a:r>
-              <a:t>- Backpressure is handled with bounded queues — each subscriber gets a 500-event buffer. If a subscriber falls behind, oldest events are dropped rather than letting memory grow unbounded.</a:t>
-            </a:r>
-          </a:p>
-          <a:p>
-            <a:r>
-              <a:t>- Dead subscribers are auto-cleaned — if a WebSocket disconnects, the server detects it and removes the subscription. No resource leaks.</a:t>
+              <a:t>- Here's the architecture side by side. Top row is traditional MCP — pull-based, request/response.</a:t>
+            </a:r>
+          </a:p>
+          <a:p>
+            <a:r>
+              <a:t>- Bottom row is what we're building: event sources feed into Kafka, Kafka feeds the MCP server, and the server pushes to agents over WebSockets.</a:t>
+            </a:r>
+          </a:p>
+          <a:p>
+            <a:r>
+              <a:t>- Why Kafka specifically? Three reasons: (1) durability — events are persisted, so if an agent disconnects and reconnects, it can replay what it missed. (2) Backpressure — Kafka handles slow consumers gracefully via consumer groups and offsets. (3) It's probably already in your infrastructure.</a:t>
+            </a:r>
+          </a:p>
+          <a:p>
+            <a:r>
+              <a:t>- The key insight is the hybrid protocol — we keep standard request/response for on-demand queries, but ADD streaming on the same WebSocket connection. The agent can subscribe to a live feed AND still ask ad-hoc questions.</a:t>
+            </a:r>
+          </a:p>
+          <a:p>
+            <a:r>
+              <a:t>- This means zero changes to existing MCP tools — we're extending, not replacing.</a:t>
             </a:r>
           </a:p>
         </p:txBody>
@@ -1208,32 +1334,32 @@
           </a:p>
           <a:p>
             <a:r>
-              <a:t>- Now, streaming data to agents raises an obvious question: who's allowed to see what?</a:t>
-            </a:r>
-          </a:p>
-          <a:p>
-            <a:r>
-              <a:t>- Cedar is an open-source authorization policy language created by AWS. It's now being adopted in the MCP ecosystem — used in Bedrock AgentCore and ToolHive for MCP tool access control.</a:t>
-            </a:r>
-          </a:p>
-          <a:p>
-            <a:r>
-              <a:t>- The model is simple: every request is evaluated as (principal, action, resource). You write permit and forbid policies declaratively.</a:t>
-            </a:r>
-          </a:p>
-          <a:p>
-            <a:r>
-              <a:t>- For our MCP server, actions include: subscribe, get_anomalies, get_context, call_tool. Resources are streams like 'app-logs' or 'audit-logs'.</a:t>
-            </a:r>
-          </a:p>
-          <a:p>
-            <a:r>
-              <a:t>- Critical design choice: default deny. If no policy matches a request, it's blocked. This is the secure-by-default posture you want for production.</a:t>
-            </a:r>
-          </a:p>
-          <a:p>
-            <a:r>
-              <a:t>- The diagram shows the flow: request comes in, Cedar evaluates policies, result is either ALLOW or DENY. No ambiguity.</a:t>
+              <a:t>- The protocol extension is minimal — we add just two new methods: subscribe and unsubscribe.</a:t>
+            </a:r>
+          </a:p>
+          <a:p>
+            <a:r>
+              <a:t>- Walk through the sequence diagram: Agent sends subscribe('app-logs'). Server starts pushing events as they arrive from Kafka. Normal log entries flow through. Then an error spike hits — the agent sees it immediately.</a:t>
+            </a:r>
+          </a:p>
+          <a:p>
+            <a:r>
+              <a:t>- Here's the hybrid part: mid-stream, the agent sends get_anomalies() — a standard request/response call — and gets back a structured anomaly summary. Both protocols coexist on the same WebSocket.</a:t>
+            </a:r>
+          </a:p>
+          <a:p>
+            <a:r>
+              <a:t>- When the agent is done, it sends unsubscribe to clean up.</a:t>
+            </a:r>
+          </a:p>
+          <a:p>
+            <a:r>
+              <a:t>- Backpressure is handled with bounded queues — each subscriber gets a 500-event buffer. If a subscriber falls behind, oldest events are dropped rather than letting memory grow unbounded.</a:t>
+            </a:r>
+          </a:p>
+          <a:p>
+            <a:r>
+              <a:t>- Dead subscribers are auto-cleaned — if a WebSocket disconnects, the server detects it and removes the subscription. No resource leaks.</a:t>
             </a:r>
           </a:p>
         </p:txBody>
@@ -1308,32 +1434,32 @@
           </a:p>
           <a:p>
             <a:r>
-              <a:t>- Let's look at real Cedar policies. These are actual policies from our demo.</a:t>
-            </a:r>
-          </a:p>
-          <a:p>
-            <a:r>
-              <a:t>- First policy: anyone can subscribe to the app-logs stream. This is your general observability data.</a:t>
-            </a:r>
-          </a:p>
-          <a:p>
-            <a:r>
-              <a:t>- Second policy: only agents with the 'ops-agent' role can call get_anomalies. You don't want every agent querying for anomaly summaries — that's an expensive operation.</a:t>
-            </a:r>
-          </a:p>
-          <a:p>
-            <a:r>
-              <a:t>- Third policy: explicitly forbid readonly agents from subscribing to audit-logs. This is sensitive compliance data.</a:t>
-            </a:r>
-          </a:p>
-          <a:p>
-            <a:r>
-              <a:t>- Key rule: forbid ALWAYS wins over permit. Even if another policy permits access, a single forbid blocks it. This prevents accidental over-permissioning.</a:t>
-            </a:r>
-          </a:p>
-          <a:p>
-            <a:r>
-              <a:t>- These policies are human-readable, auditable, and version-controllable. Your security team can review them in a PR.</a:t>
+              <a:t>- Now, streaming data to agents raises an obvious question: who's allowed to see what?</a:t>
+            </a:r>
+          </a:p>
+          <a:p>
+            <a:r>
+              <a:t>- Cedar is an open-source authorization policy language created by AWS. It's now being adopted in the MCP ecosystem — used in Bedrock AgentCore and ToolHive for MCP tool access control.</a:t>
+            </a:r>
+          </a:p>
+          <a:p>
+            <a:r>
+              <a:t>- The model is simple: every request is evaluated as (principal, action, resource). You write permit and forbid policies declaratively.</a:t>
+            </a:r>
+          </a:p>
+          <a:p>
+            <a:r>
+              <a:t>- For our MCP server, actions include: subscribe, get_anomalies, get_context, call_tool. Resources are streams like 'app-logs' or 'audit-logs'.</a:t>
+            </a:r>
+          </a:p>
+          <a:p>
+            <a:r>
+              <a:t>- Critical design choice: default deny. If no policy matches a request, it's blocked. This is the secure-by-default posture you want for production.</a:t>
+            </a:r>
+          </a:p>
+          <a:p>
+            <a:r>
+              <a:t>- The diagram shows the flow: request comes in, Cedar evaluates policies, result is either ALLOW or DENY. No ambiguity.</a:t>
             </a:r>
           </a:p>
         </p:txBody>
@@ -1408,42 +1534,32 @@
           </a:p>
           <a:p>
             <a:r>
-              <a:t>- Time for the live demo. Stack: Confluent Kafka 7.6.0 in Docker, Python 3.9, confluent-kafka 2.13.2, websockets 15.0.1.</a:t>
-            </a:r>
-          </a:p>
-          <a:p>
-            <a:r>
-              <a:t>- Here's what's running: a log simulator generates realistic application logs and pushes them to Kafka. The streaming MCP server consumes from Kafka and pushes to connected agents.</a:t>
-            </a:r>
-          </a:p>
-          <a:p>
-            <a:r>
-              <a:t>- We'll see normal traffic flowing first — INFO and DEBUG level logs streaming through in real-time.</a:t>
-            </a:r>
-          </a:p>
-          <a:p>
-            <a:r>
-              <a:t>- Then we'll trigger an error spike — simulating a production incident like a database connection failure.</a:t>
-            </a:r>
-          </a:p>
-          <a:p>
-            <a:r>
-              <a:t>- Watch the agent: it detected '🚨 ANOMALY DETECTED — error rate 60% in last 20 events' — within 1 second of the spike.</a:t>
-            </a:r>
-          </a:p>
-          <a:p>
-            <a:r>
-              <a:t>- The agent automatically suggested fixes: ConnectionRefused → check service status; OutOfMemoryError → increase JVM heap; Timeout → add circuit breaker; Deadlock → review transaction isolation.</a:t>
-            </a:r>
-          </a:p>
-          <a:p>
-            <a:r>
-              <a:t>- We'll also show Cedar in action: try subscribing with an unauthorized agent and watch it get denied.</a:t>
-            </a:r>
-          </a:p>
-          <a:p>
-            <a:r>
-              <a:t>- End-to-end latency from error occurrence to fix suggestion: under 2 seconds.</a:t>
+              <a:t>- Let's look at real Cedar policies. These are actual policies from our demo.</a:t>
+            </a:r>
+          </a:p>
+          <a:p>
+            <a:r>
+              <a:t>- First policy: anyone can subscribe to the app-logs stream. This is your general observability data.</a:t>
+            </a:r>
+          </a:p>
+          <a:p>
+            <a:r>
+              <a:t>- Second policy: only agents with the 'ops-agent' role can call get_anomalies. You don't want every agent querying for anomaly summaries — that's an expensive operation.</a:t>
+            </a:r>
+          </a:p>
+          <a:p>
+            <a:r>
+              <a:t>- Third policy: explicitly forbid readonly agents from subscribing to audit-logs. This is sensitive compliance data.</a:t>
+            </a:r>
+          </a:p>
+          <a:p>
+            <a:r>
+              <a:t>- Key rule: forbid ALWAYS wins over permit. Even if another policy permits access, a single forbid blocks it. This prevents accidental over-permissioning.</a:t>
+            </a:r>
+          </a:p>
+          <a:p>
+            <a:r>
+              <a:t>- These policies are human-readable, auditable, and version-controllable. Your security team can review them in a PR.</a:t>
             </a:r>
           </a:p>
         </p:txBody>
@@ -1518,37 +1634,42 @@
           </a:p>
           <a:p>
             <a:r>
-              <a:t>- Let's break down how anomaly detection works in this system.</a:t>
-            </a:r>
-          </a:p>
-          <a:p>
-            <a:r>
-              <a:t>- Server-side: we maintain a rolling window of the last 100 events. This gives us a stable baseline without unbounded memory growth.</a:t>
-            </a:r>
-          </a:p>
-          <a:p>
-            <a:r>
-              <a:t>- Agent-side: the agent tracks errors in a sliding 20-event window. When the error rate exceeds 30%, it triggers an anomaly alert.</a:t>
-            </a:r>
-          </a:p>
-          <a:p>
-            <a:r>
-              <a:t>- The bar chart on the right shows this visually — green bars are normal error rates, red bars are above the 30% threshold. The orange dashed line is the trigger point.</a:t>
-            </a:r>
-          </a:p>
-          <a:p>
-            <a:r>
-              <a:t>- When triggered, the agent calls get_anomalies() on the MCP server, which returns the top-N error patterns with counts and timestamps.</a:t>
-            </a:r>
-          </a:p>
-          <a:p>
-            <a:r>
-              <a:t>- The agent then maps these patterns to remediation suggestions: ConnectionError → check database connectivity and restart. OutOfMemoryError → increase heap allocation. SSLError → renew certificates.</a:t>
-            </a:r>
-          </a:p>
-          <a:p>
-            <a:r>
-              <a:t>- All of this happens within 1-2 seconds of the actual error. Compare that to the 11-minute blind spot we started with.</a:t>
+              <a:t>- Time for the live demo. Stack: Confluent Kafka 7.6.0 in Docker, Python 3.9, confluent-kafka 2.13.2, websockets 15.0.1.</a:t>
+            </a:r>
+          </a:p>
+          <a:p>
+            <a:r>
+              <a:t>- Here's what's running: a log simulator generates realistic application logs and pushes them to Kafka. The streaming MCP server consumes from Kafka and pushes to connected agents.</a:t>
+            </a:r>
+          </a:p>
+          <a:p>
+            <a:r>
+              <a:t>- We'll see normal traffic flowing first — INFO and DEBUG level logs streaming through in real-time.</a:t>
+            </a:r>
+          </a:p>
+          <a:p>
+            <a:r>
+              <a:t>- Then we'll trigger an error spike — simulating a production incident like a database connection failure.</a:t>
+            </a:r>
+          </a:p>
+          <a:p>
+            <a:r>
+              <a:t>- Watch the agent: it detected '🚨 ANOMALY DETECTED — error rate 60% in last 20 events' — within 1 second of the spike.</a:t>
+            </a:r>
+          </a:p>
+          <a:p>
+            <a:r>
+              <a:t>- The agent automatically suggested fixes: ConnectionRefused → check service status; OutOfMemoryError → increase JVM heap; Timeout → add circuit breaker; Deadlock → review transaction isolation.</a:t>
+            </a:r>
+          </a:p>
+          <a:p>
+            <a:r>
+              <a:t>- We'll also show Cedar in action: try subscribing with an unauthorized agent and watch it get denied.</a:t>
+            </a:r>
+          </a:p>
+          <a:p>
+            <a:r>
+              <a:t>- End-to-end latency from error occurrence to fix suggestion: under 2 seconds.</a:t>
             </a:r>
           </a:p>
         </p:txBody>
@@ -1623,32 +1744,37 @@
           </a:p>
           <a:p>
             <a:r>
-              <a:t>- These are the lessons learned from building this. Things that will bite you in production.</a:t>
-            </a:r>
-          </a:p>
-          <a:p>
-            <a:r>
-              <a:t>- Backpressure is #1 for a reason. If an agent can't keep up with the event stream, you need bounded queues. Our implementation uses a 500-event asyncio queue per subscriber. When full, oldest events are dropped. You could also use dead-letter topics in Kafka for events that couldn't be delivered.</a:t>
-            </a:r>
-          </a:p>
-          <a:p>
-            <a:r>
-              <a:t>- The hybrid protocol is the sweet spot. Don't force everything into streaming OR request/response. Let agents subscribe to live feeds for continuous monitoring, but also query on-demand for summaries and context. Same WebSocket, same connection.</a:t>
-            </a:r>
-          </a:p>
-          <a:p>
-            <a:r>
-              <a:t>- Kafka consumer groups are powerful but confusing. Same group ID = events are load-balanced across consumers (each event goes to ONE consumer). Different group IDs = fan-out (each event goes to ALL consumers). Choose based on your use case.</a:t>
-            </a:r>
-          </a:p>
-          <a:p>
-            <a:r>
-              <a:t>- Reconnection strategy matters. Use exponential backoff to avoid thundering herd. On reconnect, send a context snapshot so the agent doesn't start from zero.</a:t>
-            </a:r>
-          </a:p>
-          <a:p>
-            <a:r>
-              <a:t>- Be selective about what you stream. Errors and anomalies? Stream them. Normal INFO-level metrics? Batch those and let agents poll. Don't flood the pipe with noise.</a:t>
+              <a:t>- Let's break down how anomaly detection works in this system.</a:t>
+            </a:r>
+          </a:p>
+          <a:p>
+            <a:r>
+              <a:t>- Server-side: we maintain a rolling window of the last 100 events. This gives us a stable baseline without unbounded memory growth.</a:t>
+            </a:r>
+          </a:p>
+          <a:p>
+            <a:r>
+              <a:t>- Agent-side: the agent tracks errors in a sliding 20-event window. When the error rate exceeds 30%, it triggers an anomaly alert.</a:t>
+            </a:r>
+          </a:p>
+          <a:p>
+            <a:r>
+              <a:t>- The bar chart on the right shows this visually — green bars are normal error rates, red bars are above the 30% threshold. The orange dashed line is the trigger point.</a:t>
+            </a:r>
+          </a:p>
+          <a:p>
+            <a:r>
+              <a:t>- When triggered, the agent calls get_anomalies() on the MCP server, which returns the top-N error patterns with counts and timestamps.</a:t>
+            </a:r>
+          </a:p>
+          <a:p>
+            <a:r>
+              <a:t>- The agent then maps these patterns to remediation suggestions: ConnectionError → check database connectivity and restart. OutOfMemoryError → increase heap allocation. SSLError → renew certificates.</a:t>
+            </a:r>
+          </a:p>
+          <a:p>
+            <a:r>
+              <a:t>- All of this happens within 1-2 seconds of the actual error. Compare that to the 11-minute blind spot we started with.</a:t>
             </a:r>
           </a:p>
         </p:txBody>
@@ -4799,7 +4925,7 @@
               </a:defRPr>
             </a:pPr>
             <a:r>
-              <a:t>What Streaming MCP Unlocks</a:t>
+              <a:t>Production Patterns &amp; Gotchas</a:t>
             </a:r>
           </a:p>
         </p:txBody>
@@ -4813,7 +4939,7 @@
         <p:spPr>
           <a:xfrm>
             <a:off x="914400" y="1280160"/>
-            <a:ext cx="5029200" cy="4754880"/>
+            <a:ext cx="10058400" cy="4754880"/>
           </a:xfrm>
           <a:prstGeom prst="rect">
             <a:avLst/>
@@ -4838,7 +4964,7 @@
               </a:defRPr>
             </a:pPr>
             <a:r>
-              <a:t>DevOps — real-time incident detection and auto-remediation</a:t>
+              <a:t>1. Backpressure: bounded queues, drop slow subscribers</a:t>
             </a:r>
           </a:p>
           <a:p>
@@ -4854,7 +4980,7 @@
               </a:defRPr>
             </a:pPr>
             <a:r>
-              <a:t>Trading — live market data feeding AI decision agents</a:t>
+              <a:t>2. Hybrid protocol: streaming AND on-demand on same WebSocket</a:t>
             </a:r>
           </a:p>
           <a:p>
@@ -4870,7 +4996,7 @@
               </a:defRPr>
             </a:pPr>
             <a:r>
-              <a:t>Security — streaming audit logs with Cedar-authorized access</a:t>
+              <a:t>3. Kafka consumer groups: same = load balance, different = fan-out</a:t>
             </a:r>
           </a:p>
           <a:p>
@@ -4886,7 +5012,7 @@
               </a:defRPr>
             </a:pPr>
             <a:r>
-              <a:t>CI/CD — file watchers notifying agents of code changes</a:t>
+              <a:t>4. Reconnection: exponential backoff + context snapshot</a:t>
             </a:r>
           </a:p>
           <a:p>
@@ -4902,35 +5028,11 @@
               </a:defRPr>
             </a:pPr>
             <a:r>
-              <a:t>IoT — sensor data streaming to predictive maintenance agents</a:t>
-            </a:r>
-          </a:p>
-        </p:txBody>
-      </p:sp>
-      <p:pic>
-        <p:nvPicPr>
-          <p:cNvPr id="4" name="Picture 3" descr="image.png"/>
-          <p:cNvPicPr>
-            <a:picLocks noChangeAspect="1"/>
-          </p:cNvPicPr>
-          <p:nvPr/>
-        </p:nvPicPr>
-        <p:blipFill>
-          <a:blip r:embed="rId3"/>
-          <a:stretch>
-            <a:fillRect/>
-          </a:stretch>
-        </p:blipFill>
-        <p:spPr>
-          <a:xfrm>
-            <a:off x="6217920" y="1280160"/>
-            <a:ext cx="5486400" cy="4572000"/>
-          </a:xfrm>
-          <a:prstGeom prst="rect">
-            <a:avLst/>
-          </a:prstGeom>
-        </p:spPr>
-      </p:pic>
+              <a:t>5. Be selective: stream errors &amp; anomalies, batch normal metrics</a:t>
+            </a:r>
+          </a:p>
+        </p:txBody>
+      </p:sp>
     </p:spTree>
   </p:cSld>
   <p:clrMapOvr>
@@ -4988,7 +5090,7 @@
               </a:defRPr>
             </a:pPr>
             <a:r>
-              <a:t>Key Takeaways</a:t>
+              <a:t>What Streaming MCP Unlocks</a:t>
             </a:r>
           </a:p>
         </p:txBody>
@@ -5027,7 +5129,7 @@
               </a:defRPr>
             </a:pPr>
             <a:r>
-              <a:t>MCP doesn't have to be request/response only</a:t>
+              <a:t>DevOps — real-time incident detection and auto-remediation</a:t>
             </a:r>
           </a:p>
           <a:p>
@@ -5043,7 +5145,7 @@
               </a:defRPr>
             </a:pPr>
             <a:r>
-              <a:t>Kafka (Confluent 7.6.0) + WebSocket = durable, scalable streaming bridge</a:t>
+              <a:t>Trading — live market data feeding AI decision agents</a:t>
             </a:r>
           </a:p>
           <a:p>
@@ -5059,7 +5161,7 @@
               </a:defRPr>
             </a:pPr>
             <a:r>
-              <a:t>Cedar provides declarative, auditable authorization for MCP</a:t>
+              <a:t>Security — streaming audit logs with Cedar-authorized access</a:t>
             </a:r>
           </a:p>
           <a:p>
@@ -5075,7 +5177,7 @@
               </a:defRPr>
             </a:pPr>
             <a:r>
-              <a:t>Hybrid protocol (push + pull) on single connection is the sweet spot</a:t>
+              <a:t>CI/CD — file watchers notifying agents of code changes</a:t>
             </a:r>
           </a:p>
           <a:p>
@@ -5091,7 +5193,7 @@
               </a:defRPr>
             </a:pPr>
             <a:r>
-              <a:t>All open source — Python 3.9+, Docker, ~200 lines of code</a:t>
+              <a:t>IoT — sensor data streaming to predictive maintenance agents</a:t>
             </a:r>
           </a:p>
         </p:txBody>
@@ -5154,6 +5256,195 @@
         </p:nvSpPr>
         <p:spPr>
           <a:xfrm>
+            <a:off x="731520" y="274320"/>
+            <a:ext cx="10058400" cy="731520"/>
+          </a:xfrm>
+          <a:prstGeom prst="rect">
+            <a:avLst/>
+          </a:prstGeom>
+          <a:noFill/>
+        </p:spPr>
+        <p:txBody>
+          <a:bodyPr wrap="square">
+            <a:spAutoFit/>
+          </a:bodyPr>
+          <a:lstStyle/>
+          <a:p>
+            <a:pPr algn="l">
+              <a:defRPr sz="3200" b="1">
+                <a:solidFill>
+                  <a:srgbClr val="00D4AA"/>
+                </a:solidFill>
+                <a:latin typeface="Calibri"/>
+              </a:defRPr>
+            </a:pPr>
+            <a:r>
+              <a:t>Key Takeaways</a:t>
+            </a:r>
+          </a:p>
+        </p:txBody>
+      </p:sp>
+      <p:sp>
+        <p:nvSpPr>
+          <p:cNvPr id="3" name="TextBox 2"/>
+          <p:cNvSpPr txBox="1"/>
+          <p:nvPr/>
+        </p:nvSpPr>
+        <p:spPr>
+          <a:xfrm>
+            <a:off x="914400" y="1280160"/>
+            <a:ext cx="5029200" cy="4754880"/>
+          </a:xfrm>
+          <a:prstGeom prst="rect">
+            <a:avLst/>
+          </a:prstGeom>
+          <a:noFill/>
+        </p:spPr>
+        <p:txBody>
+          <a:bodyPr wrap="square">
+            <a:spAutoFit/>
+          </a:bodyPr>
+          <a:lstStyle/>
+          <a:p>
+            <a:pPr>
+              <a:spcAft>
+                <a:spcPts val="800"/>
+              </a:spcAft>
+              <a:defRPr sz="1800">
+                <a:solidFill>
+                  <a:srgbClr val="FFFFFF"/>
+                </a:solidFill>
+                <a:latin typeface="Calibri"/>
+              </a:defRPr>
+            </a:pPr>
+            <a:r>
+              <a:t>MCP doesn't have to be request/response only</a:t>
+            </a:r>
+          </a:p>
+          <a:p>
+            <a:pPr>
+              <a:spcAft>
+                <a:spcPts val="800"/>
+              </a:spcAft>
+              <a:defRPr sz="1800">
+                <a:solidFill>
+                  <a:srgbClr val="FFFFFF"/>
+                </a:solidFill>
+                <a:latin typeface="Calibri"/>
+              </a:defRPr>
+            </a:pPr>
+            <a:r>
+              <a:t>Kafka (Confluent 7.6.0) + WebSocket = durable, scalable streaming bridge</a:t>
+            </a:r>
+          </a:p>
+          <a:p>
+            <a:pPr>
+              <a:spcAft>
+                <a:spcPts val="800"/>
+              </a:spcAft>
+              <a:defRPr sz="1800">
+                <a:solidFill>
+                  <a:srgbClr val="FFFFFF"/>
+                </a:solidFill>
+                <a:latin typeface="Calibri"/>
+              </a:defRPr>
+            </a:pPr>
+            <a:r>
+              <a:t>Cedar provides declarative, auditable authorization for MCP</a:t>
+            </a:r>
+          </a:p>
+          <a:p>
+            <a:pPr>
+              <a:spcAft>
+                <a:spcPts val="800"/>
+              </a:spcAft>
+              <a:defRPr sz="1800">
+                <a:solidFill>
+                  <a:srgbClr val="FFFFFF"/>
+                </a:solidFill>
+                <a:latin typeface="Calibri"/>
+              </a:defRPr>
+            </a:pPr>
+            <a:r>
+              <a:t>Hybrid protocol (push + pull) on single connection is the sweet spot</a:t>
+            </a:r>
+          </a:p>
+          <a:p>
+            <a:pPr>
+              <a:spcAft>
+                <a:spcPts val="800"/>
+              </a:spcAft>
+              <a:defRPr sz="1800">
+                <a:solidFill>
+                  <a:srgbClr val="FFFFFF"/>
+                </a:solidFill>
+                <a:latin typeface="Calibri"/>
+              </a:defRPr>
+            </a:pPr>
+            <a:r>
+              <a:t>All open source — Python 3.9+, Docker, ~200 lines of code</a:t>
+            </a:r>
+          </a:p>
+        </p:txBody>
+      </p:sp>
+      <p:pic>
+        <p:nvPicPr>
+          <p:cNvPr id="4" name="Picture 3" descr="image.png"/>
+          <p:cNvPicPr>
+            <a:picLocks noChangeAspect="1"/>
+          </p:cNvPicPr>
+          <p:nvPr/>
+        </p:nvPicPr>
+        <p:blipFill>
+          <a:blip r:embed="rId3"/>
+          <a:stretch>
+            <a:fillRect/>
+          </a:stretch>
+        </p:blipFill>
+        <p:spPr>
+          <a:xfrm>
+            <a:off x="6217920" y="1280160"/>
+            <a:ext cx="5486400" cy="4572000"/>
+          </a:xfrm>
+          <a:prstGeom prst="rect">
+            <a:avLst/>
+          </a:prstGeom>
+        </p:spPr>
+      </p:pic>
+    </p:spTree>
+  </p:cSld>
+  <p:clrMapOvr>
+    <a:masterClrMapping/>
+  </p:clrMapOvr>
+</p:sld>
+</file>
+
+<file path=ppt/slides/slide13.xml><?xml version="1.0" encoding="utf-8"?>
+<p:sld xmlns:a="http://schemas.openxmlformats.org/drawingml/2006/main" xmlns:p="http://schemas.openxmlformats.org/presentationml/2006/main" xmlns:r="http://schemas.openxmlformats.org/officeDocument/2006/relationships">
+  <p:cSld>
+    <p:bg>
+      <p:bgPr>
+        <a:solidFill>
+          <a:srgbClr val="1B1B2F"/>
+        </a:solidFill>
+        <a:effectLst/>
+      </p:bgPr>
+    </p:bg>
+    <p:spTree>
+      <p:nvGrpSpPr>
+        <p:cNvPr id="1" name=""/>
+        <p:cNvGrpSpPr/>
+        <p:nvPr/>
+      </p:nvGrpSpPr>
+      <p:grpSpPr/>
+      <p:sp>
+        <p:nvSpPr>
+          <p:cNvPr id="2" name="TextBox 1"/>
+          <p:cNvSpPr txBox="1"/>
+          <p:nvPr/>
+        </p:nvSpPr>
+        <p:spPr>
+          <a:xfrm>
             <a:off x="914400" y="1828800"/>
             <a:ext cx="10058400" cy="2286000"/>
           </a:xfrm>
@@ -5279,7 +5570,7 @@
               </a:defRPr>
             </a:pPr>
             <a:r>
-              <a:t>The Stale Context Problem</a:t>
+              <a:t>System Architecture</a:t>
             </a:r>
           </a:p>
         </p:txBody>
@@ -5310,7 +5601,7 @@
               <a:spcAft>
                 <a:spcPts val="800"/>
               </a:spcAft>
-              <a:defRPr sz="1800">
+              <a:defRPr sz="1600">
                 <a:solidFill>
                   <a:srgbClr val="FFFFFF"/>
                 </a:solidFill>
@@ -5318,7 +5609,7 @@
               </a:defRPr>
             </a:pPr>
             <a:r>
-              <a:t>Traditional MCP = request/response snapshots</a:t>
+              <a:t>Log Simulator produces events to Kafka (app-logs topic)</a:t>
             </a:r>
           </a:p>
           <a:p>
@@ -5326,7 +5617,7 @@
               <a:spcAft>
                 <a:spcPts val="800"/>
               </a:spcAft>
-              <a:defRPr sz="1800">
+              <a:defRPr sz="1600">
                 <a:solidFill>
                   <a:srgbClr val="FFFFFF"/>
                 </a:solidFill>
@@ -5334,7 +5625,7 @@
               </a:defRPr>
             </a:pPr>
             <a:r>
-              <a:t>Agent asks for logs → gets point-in-time dump → works with stale data</a:t>
+              <a:t>MCP Server consumes from Kafka, maintains rolling window</a:t>
             </a:r>
           </a:p>
           <a:p>
@@ -5342,7 +5633,7 @@
               <a:spcAft>
                 <a:spcPts val="800"/>
               </a:spcAft>
-              <a:defRPr sz="1800">
+              <a:defRPr sz="1600">
                 <a:solidFill>
                   <a:srgbClr val="FFFFFF"/>
                 </a:solidFill>
@@ -5350,7 +5641,7 @@
               </a:defRPr>
             </a:pPr>
             <a:r>
-              <a:t>Deploy at 2:03pm, errors spike at 2:04pm, agent doesn't know until 2:15pm</a:t>
+              <a:t>Anomaly Detection tracks error rates server-side</a:t>
             </a:r>
           </a:p>
           <a:p>
@@ -5358,7 +5649,7 @@
               <a:spcAft>
                 <a:spcPts val="800"/>
               </a:spcAft>
-              <a:defRPr sz="1800">
+              <a:defRPr sz="1600">
                 <a:solidFill>
                   <a:srgbClr val="FFFFFF"/>
                 </a:solidFill>
@@ -5366,7 +5657,71 @@
               </a:defRPr>
             </a:pPr>
             <a:r>
-              <a:t>What if context came TO the agent, as it happened?</a:t>
+              <a:t>WebSocket Server pushes live events to subscribed agents</a:t>
+            </a:r>
+          </a:p>
+          <a:p>
+            <a:pPr>
+              <a:spcAft>
+                <a:spcPts val="800"/>
+              </a:spcAft>
+              <a:defRPr sz="1600">
+                <a:solidFill>
+                  <a:srgbClr val="FFFFFF"/>
+                </a:solidFill>
+                <a:latin typeface="Calibri"/>
+              </a:defRPr>
+            </a:pPr>
+            <a:r>
+              <a:t>Cedar Policy Engine enforces permit/forbid on every action</a:t>
+            </a:r>
+          </a:p>
+          <a:p>
+            <a:pPr>
+              <a:spcAft>
+                <a:spcPts val="800"/>
+              </a:spcAft>
+              <a:defRPr sz="1600">
+                <a:solidFill>
+                  <a:srgbClr val="FFFFFF"/>
+                </a:solidFill>
+                <a:latin typeface="Calibri"/>
+              </a:defRPr>
+            </a:pPr>
+            <a:r>
+              <a:t>AI Agent subscribes, monitors 20-event sliding window</a:t>
+            </a:r>
+          </a:p>
+          <a:p>
+            <a:pPr>
+              <a:spcAft>
+                <a:spcPts val="800"/>
+              </a:spcAft>
+              <a:defRPr sz="1600">
+                <a:solidFill>
+                  <a:srgbClr val="FFFFFF"/>
+                </a:solidFill>
+                <a:latin typeface="Calibri"/>
+              </a:defRPr>
+            </a:pPr>
+            <a:r>
+              <a:t>Remediation Engine maps error patterns to fix suggestions</a:t>
+            </a:r>
+          </a:p>
+          <a:p>
+            <a:pPr>
+              <a:spcAft>
+                <a:spcPts val="800"/>
+              </a:spcAft>
+              <a:defRPr sz="1600">
+                <a:solidFill>
+                  <a:srgbClr val="FFFFFF"/>
+                </a:solidFill>
+                <a:latin typeface="Calibri"/>
+              </a:defRPr>
+            </a:pPr>
+            <a:r>
+              <a:t>Hybrid: push (streaming) + pull (get_anomalies) on same connection</a:t>
             </a:r>
           </a:p>
         </p:txBody>
@@ -5452,7 +5807,7 @@
               </a:defRPr>
             </a:pPr>
             <a:r>
-              <a:t>Streaming MCP Architecture</a:t>
+              <a:t>The Stale Context Problem</a:t>
             </a:r>
           </a:p>
         </p:txBody>
@@ -5491,7 +5846,7 @@
               </a:defRPr>
             </a:pPr>
             <a:r>
-              <a:t>Standard MCP: Client → Server → Response (pull model)</a:t>
+              <a:t>Traditional MCP = request/response snapshots</a:t>
             </a:r>
           </a:p>
           <a:p>
@@ -5507,7 +5862,7 @@
               </a:defRPr>
             </a:pPr>
             <a:r>
-              <a:t>Streaming MCP: Server → Client via subscriptions (push model)</a:t>
+              <a:t>Agent asks for logs → gets point-in-time dump → works with stale data</a:t>
             </a:r>
           </a:p>
           <a:p>
@@ -5523,7 +5878,7 @@
               </a:defRPr>
             </a:pPr>
             <a:r>
-              <a:t>Why Kafka: durable, replayable, backpressure handling</a:t>
+              <a:t>Deploy at 2:03pm, errors spike at 2:04pm, agent doesn't know until 2:15pm</a:t>
             </a:r>
           </a:p>
           <a:p>
@@ -5539,7 +5894,7 @@
               </a:defRPr>
             </a:pPr>
             <a:r>
-              <a:t>Hybrid protocol: streaming + request/response on same connection</a:t>
+              <a:t>What if context came TO the agent, as it happened?</a:t>
             </a:r>
           </a:p>
         </p:txBody>
@@ -5625,7 +5980,7 @@
               </a:defRPr>
             </a:pPr>
             <a:r>
-              <a:t>Key Protocol Extension: subscribe</a:t>
+              <a:t>Streaming MCP Architecture</a:t>
             </a:r>
           </a:p>
         </p:txBody>
@@ -5664,7 +6019,7 @@
               </a:defRPr>
             </a:pPr>
             <a:r>
-              <a:t>New method: subscribe / unsubscribe for continuous push</a:t>
+              <a:t>Standard MCP: Client → Server → Response (pull model)</a:t>
             </a:r>
           </a:p>
           <a:p>
@@ -5680,7 +6035,7 @@
               </a:defRPr>
             </a:pPr>
             <a:r>
-              <a:t>Still supports get_anomalies, get_context (standard request/response)</a:t>
+              <a:t>Streaming MCP: Server → Client via subscriptions (push model)</a:t>
             </a:r>
           </a:p>
           <a:p>
@@ -5696,7 +6051,23 @@
               </a:defRPr>
             </a:pPr>
             <a:r>
-              <a:t>Bounded queues (500 events) handle backpressure automatically</a:t>
+              <a:t>Why Kafka: durable, replayable, backpressure handling</a:t>
+            </a:r>
+          </a:p>
+          <a:p>
+            <a:pPr>
+              <a:spcAft>
+                <a:spcPts val="800"/>
+              </a:spcAft>
+              <a:defRPr sz="1800">
+                <a:solidFill>
+                  <a:srgbClr val="FFFFFF"/>
+                </a:solidFill>
+                <a:latin typeface="Calibri"/>
+              </a:defRPr>
+            </a:pPr>
+            <a:r>
+              <a:t>Hybrid protocol: streaming + request/response on same connection</a:t>
             </a:r>
           </a:p>
         </p:txBody>
@@ -5782,7 +6153,7 @@
               </a:defRPr>
             </a:pPr>
             <a:r>
-              <a:t>Cedar Authorization for MCP</a:t>
+              <a:t>Key Protocol Extension: subscribe</a:t>
             </a:r>
           </a:p>
         </p:txBody>
@@ -5821,7 +6192,7 @@
               </a:defRPr>
             </a:pPr>
             <a:r>
-              <a:t>Open-source policy language by AWS</a:t>
+              <a:t>New method: subscribe / unsubscribe for continuous push</a:t>
             </a:r>
           </a:p>
           <a:p>
@@ -5837,7 +6208,7 @@
               </a:defRPr>
             </a:pPr>
             <a:r>
-              <a:t>Declarative: permit/forbid(principal, action, resource)</a:t>
+              <a:t>Still supports get_anomalies, get_context (standard request/response)</a:t>
             </a:r>
           </a:p>
           <a:p>
@@ -5853,23 +6224,7 @@
               </a:defRPr>
             </a:pPr>
             <a:r>
-              <a:t>Role-based access control for MCP actions</a:t>
-            </a:r>
-          </a:p>
-          <a:p>
-            <a:pPr>
-              <a:spcAft>
-                <a:spcPts val="800"/>
-              </a:spcAft>
-              <a:defRPr sz="1800">
-                <a:solidFill>
-                  <a:srgbClr val="FFFFFF"/>
-                </a:solidFill>
-                <a:latin typeface="Calibri"/>
-              </a:defRPr>
-            </a:pPr>
-            <a:r>
-              <a:t>Default deny — no matching policy = request denied</a:t>
+              <a:t>Bounded queues (500 events) handle backpressure automatically</a:t>
             </a:r>
           </a:p>
         </p:txBody>
@@ -5955,164 +6310,7 @@
               </a:defRPr>
             </a:pPr>
             <a:r>
-              <a:t>Cedar Policy Examples</a:t>
-            </a:r>
-          </a:p>
-        </p:txBody>
-      </p:sp>
-      <p:sp>
-        <p:nvSpPr>
-          <p:cNvPr id="3" name="TextBox 2"/>
-          <p:cNvSpPr txBox="1"/>
-          <p:nvPr/>
-        </p:nvSpPr>
-        <p:spPr>
-          <a:xfrm>
-            <a:off x="914400" y="1280160"/>
-            <a:ext cx="10058400" cy="4754880"/>
-          </a:xfrm>
-          <a:prstGeom prst="rect">
-            <a:avLst/>
-          </a:prstGeom>
-          <a:noFill/>
-        </p:spPr>
-        <p:txBody>
-          <a:bodyPr wrap="square">
-            <a:spAutoFit/>
-          </a:bodyPr>
-          <a:lstStyle/>
-          <a:p>
-            <a:pPr>
-              <a:spcAft>
-                <a:spcPts val="800"/>
-              </a:spcAft>
-              <a:defRPr sz="1600">
-                <a:solidFill>
-                  <a:srgbClr val="FFFFFF"/>
-                </a:solidFill>
-                <a:latin typeface="Calibri"/>
-              </a:defRPr>
-            </a:pPr>
-            <a:r>
-              <a:t>permit(principal, action == Action::"subscribe", resource == Stream::"app-logs");</a:t>
-            </a:r>
-          </a:p>
-          <a:p>
-            <a:pPr>
-              <a:spcAft>
-                <a:spcPts val="800"/>
-              </a:spcAft>
-              <a:defRPr sz="1600">
-                <a:solidFill>
-                  <a:srgbClr val="FFFFFF"/>
-                </a:solidFill>
-                <a:latin typeface="Calibri"/>
-              </a:defRPr>
-            </a:pPr>
-            <a:r>
-              <a:t>permit(principal, action == Action::"get_anomalies", resource)</a:t>
-            </a:r>
-            <a:br/>
-            <a:r>
-              <a:t>    when { principal.role == "ops-agent" };</a:t>
-            </a:r>
-          </a:p>
-          <a:p>
-            <a:pPr>
-              <a:spcAft>
-                <a:spcPts val="800"/>
-              </a:spcAft>
-              <a:defRPr sz="1600">
-                <a:solidFill>
-                  <a:srgbClr val="FFFFFF"/>
-                </a:solidFill>
-                <a:latin typeface="Calibri"/>
-              </a:defRPr>
-            </a:pPr>
-            <a:r>
-              <a:t>forbid(principal, action == Action::"subscribe", resource == Stream::"audit-logs")</a:t>
-            </a:r>
-            <a:br/>
-            <a:r>
-              <a:t>    when { principal.role == "readonly" };</a:t>
-            </a:r>
-          </a:p>
-          <a:p>
-            <a:pPr>
-              <a:spcAft>
-                <a:spcPts val="800"/>
-              </a:spcAft>
-              <a:defRPr sz="1600">
-                <a:solidFill>
-                  <a:srgbClr val="FFFFFF"/>
-                </a:solidFill>
-                <a:latin typeface="Calibri"/>
-              </a:defRPr>
-            </a:pPr>
-            <a:r>
-              <a:t>Forbid always wins over permit — secure by default</a:t>
-            </a:r>
-          </a:p>
-        </p:txBody>
-      </p:sp>
-    </p:spTree>
-  </p:cSld>
-  <p:clrMapOvr>
-    <a:masterClrMapping/>
-  </p:clrMapOvr>
-</p:sld>
-</file>
-
-<file path=ppt/slides/slide7.xml><?xml version="1.0" encoding="utf-8"?>
-<p:sld xmlns:a="http://schemas.openxmlformats.org/drawingml/2006/main" xmlns:p="http://schemas.openxmlformats.org/presentationml/2006/main" xmlns:r="http://schemas.openxmlformats.org/officeDocument/2006/relationships">
-  <p:cSld>
-    <p:bg>
-      <p:bgPr>
-        <a:solidFill>
-          <a:srgbClr val="1B1B2F"/>
-        </a:solidFill>
-        <a:effectLst/>
-      </p:bgPr>
-    </p:bg>
-    <p:spTree>
-      <p:nvGrpSpPr>
-        <p:cNvPr id="1" name=""/>
-        <p:cNvGrpSpPr/>
-        <p:nvPr/>
-      </p:nvGrpSpPr>
-      <p:grpSpPr/>
-      <p:sp>
-        <p:nvSpPr>
-          <p:cNvPr id="2" name="TextBox 1"/>
-          <p:cNvSpPr txBox="1"/>
-          <p:nvPr/>
-        </p:nvSpPr>
-        <p:spPr>
-          <a:xfrm>
-            <a:off x="731520" y="274320"/>
-            <a:ext cx="10058400" cy="731520"/>
-          </a:xfrm>
-          <a:prstGeom prst="rect">
-            <a:avLst/>
-          </a:prstGeom>
-          <a:noFill/>
-        </p:spPr>
-        <p:txBody>
-          <a:bodyPr wrap="square">
-            <a:spAutoFit/>
-          </a:bodyPr>
-          <a:lstStyle/>
-          <a:p>
-            <a:pPr algn="l">
-              <a:defRPr sz="3200" b="1">
-                <a:solidFill>
-                  <a:srgbClr val="00D4AA"/>
-                </a:solidFill>
-                <a:latin typeface="Calibri"/>
-              </a:defRPr>
-            </a:pPr>
-            <a:r>
-              <a:t>Live Demo: Real-time Log Monitoring</a:t>
+              <a:t>Cedar Authorization for MCP</a:t>
             </a:r>
           </a:p>
         </p:txBody>
@@ -6151,7 +6349,7 @@
               </a:defRPr>
             </a:pPr>
             <a:r>
-              <a:t>Log simulator → Kafka → MCP Server → AI Agent</a:t>
+              <a:t>Open-source policy language by AWS</a:t>
             </a:r>
           </a:p>
           <a:p>
@@ -6167,7 +6365,7 @@
               </a:defRPr>
             </a:pPr>
             <a:r>
-              <a:t>Error spike → agent detects anomaly within 1 second</a:t>
+              <a:t>Declarative: permit/forbid(principal, action, resource)</a:t>
             </a:r>
           </a:p>
           <a:p>
@@ -6183,7 +6381,7 @@
               </a:defRPr>
             </a:pPr>
             <a:r>
-              <a:t>Agent queries for anomaly summary mid-stream</a:t>
+              <a:t>Role-based access control for MCP actions</a:t>
             </a:r>
           </a:p>
           <a:p>
@@ -6199,7 +6397,7 @@
               </a:defRPr>
             </a:pPr>
             <a:r>
-              <a:t>Cedar blocks unauthorized agents from sensitive streams</a:t>
+              <a:t>Default deny — no matching policy = request denied</a:t>
             </a:r>
           </a:p>
         </p:txBody>
@@ -6236,6 +6434,163 @@
 </p:sld>
 </file>
 
+<file path=ppt/slides/slide7.xml><?xml version="1.0" encoding="utf-8"?>
+<p:sld xmlns:a="http://schemas.openxmlformats.org/drawingml/2006/main" xmlns:p="http://schemas.openxmlformats.org/presentationml/2006/main" xmlns:r="http://schemas.openxmlformats.org/officeDocument/2006/relationships">
+  <p:cSld>
+    <p:bg>
+      <p:bgPr>
+        <a:solidFill>
+          <a:srgbClr val="1B1B2F"/>
+        </a:solidFill>
+        <a:effectLst/>
+      </p:bgPr>
+    </p:bg>
+    <p:spTree>
+      <p:nvGrpSpPr>
+        <p:cNvPr id="1" name=""/>
+        <p:cNvGrpSpPr/>
+        <p:nvPr/>
+      </p:nvGrpSpPr>
+      <p:grpSpPr/>
+      <p:sp>
+        <p:nvSpPr>
+          <p:cNvPr id="2" name="TextBox 1"/>
+          <p:cNvSpPr txBox="1"/>
+          <p:nvPr/>
+        </p:nvSpPr>
+        <p:spPr>
+          <a:xfrm>
+            <a:off x="731520" y="274320"/>
+            <a:ext cx="10058400" cy="731520"/>
+          </a:xfrm>
+          <a:prstGeom prst="rect">
+            <a:avLst/>
+          </a:prstGeom>
+          <a:noFill/>
+        </p:spPr>
+        <p:txBody>
+          <a:bodyPr wrap="square">
+            <a:spAutoFit/>
+          </a:bodyPr>
+          <a:lstStyle/>
+          <a:p>
+            <a:pPr algn="l">
+              <a:defRPr sz="3200" b="1">
+                <a:solidFill>
+                  <a:srgbClr val="00D4AA"/>
+                </a:solidFill>
+                <a:latin typeface="Calibri"/>
+              </a:defRPr>
+            </a:pPr>
+            <a:r>
+              <a:t>Cedar Policy Examples</a:t>
+            </a:r>
+          </a:p>
+        </p:txBody>
+      </p:sp>
+      <p:sp>
+        <p:nvSpPr>
+          <p:cNvPr id="3" name="TextBox 2"/>
+          <p:cNvSpPr txBox="1"/>
+          <p:nvPr/>
+        </p:nvSpPr>
+        <p:spPr>
+          <a:xfrm>
+            <a:off x="914400" y="1280160"/>
+            <a:ext cx="10058400" cy="4754880"/>
+          </a:xfrm>
+          <a:prstGeom prst="rect">
+            <a:avLst/>
+          </a:prstGeom>
+          <a:noFill/>
+        </p:spPr>
+        <p:txBody>
+          <a:bodyPr wrap="square">
+            <a:spAutoFit/>
+          </a:bodyPr>
+          <a:lstStyle/>
+          <a:p>
+            <a:pPr>
+              <a:spcAft>
+                <a:spcPts val="800"/>
+              </a:spcAft>
+              <a:defRPr sz="1600">
+                <a:solidFill>
+                  <a:srgbClr val="FFFFFF"/>
+                </a:solidFill>
+                <a:latin typeface="Calibri"/>
+              </a:defRPr>
+            </a:pPr>
+            <a:r>
+              <a:t>permit(principal, action == Action::"subscribe", resource == Stream::"app-logs");</a:t>
+            </a:r>
+          </a:p>
+          <a:p>
+            <a:pPr>
+              <a:spcAft>
+                <a:spcPts val="800"/>
+              </a:spcAft>
+              <a:defRPr sz="1600">
+                <a:solidFill>
+                  <a:srgbClr val="FFFFFF"/>
+                </a:solidFill>
+                <a:latin typeface="Calibri"/>
+              </a:defRPr>
+            </a:pPr>
+            <a:r>
+              <a:t>permit(principal, action == Action::"get_anomalies", resource)</a:t>
+            </a:r>
+            <a:br/>
+            <a:r>
+              <a:t>    when { principal.role == "ops-agent" };</a:t>
+            </a:r>
+          </a:p>
+          <a:p>
+            <a:pPr>
+              <a:spcAft>
+                <a:spcPts val="800"/>
+              </a:spcAft>
+              <a:defRPr sz="1600">
+                <a:solidFill>
+                  <a:srgbClr val="FFFFFF"/>
+                </a:solidFill>
+                <a:latin typeface="Calibri"/>
+              </a:defRPr>
+            </a:pPr>
+            <a:r>
+              <a:t>forbid(principal, action == Action::"subscribe", resource == Stream::"audit-logs")</a:t>
+            </a:r>
+            <a:br/>
+            <a:r>
+              <a:t>    when { principal.role == "readonly" };</a:t>
+            </a:r>
+          </a:p>
+          <a:p>
+            <a:pPr>
+              <a:spcAft>
+                <a:spcPts val="800"/>
+              </a:spcAft>
+              <a:defRPr sz="1600">
+                <a:solidFill>
+                  <a:srgbClr val="FFFFFF"/>
+                </a:solidFill>
+                <a:latin typeface="Calibri"/>
+              </a:defRPr>
+            </a:pPr>
+            <a:r>
+              <a:t>Forbid always wins over permit — secure by default</a:t>
+            </a:r>
+          </a:p>
+        </p:txBody>
+      </p:sp>
+    </p:spTree>
+  </p:cSld>
+  <p:clrMapOvr>
+    <a:masterClrMapping/>
+  </p:clrMapOvr>
+</p:sld>
+</file>
+
 <file path=ppt/slides/slide8.xml><?xml version="1.0" encoding="utf-8"?>
 <p:sld xmlns:a="http://schemas.openxmlformats.org/drawingml/2006/main" xmlns:p="http://schemas.openxmlformats.org/presentationml/2006/main" xmlns:r="http://schemas.openxmlformats.org/officeDocument/2006/relationships">
   <p:cSld>
@@ -6285,7 +6640,7 @@
               </a:defRPr>
             </a:pPr>
             <a:r>
-              <a:t>Anomaly Detection Flow</a:t>
+              <a:t>Live Demo: Real-time Log Monitoring</a:t>
             </a:r>
           </a:p>
         </p:txBody>
@@ -6324,7 +6679,7 @@
               </a:defRPr>
             </a:pPr>
             <a:r>
-              <a:t>Rolling window of last 100 events maintained server-side</a:t>
+              <a:t>Log simulator → Kafka → MCP Server → AI Agent</a:t>
             </a:r>
           </a:p>
           <a:p>
@@ -6340,7 +6695,7 @@
               </a:defRPr>
             </a:pPr>
             <a:r>
-              <a:t>Error rate &gt; 30% triggers anomaly alert</a:t>
+              <a:t>Error spike → agent detects anomaly within 1 second</a:t>
             </a:r>
           </a:p>
           <a:p>
@@ -6356,7 +6711,23 @@
               </a:defRPr>
             </a:pPr>
             <a:r>
-              <a:t>Agent maps error patterns to fix suggestions automatically</a:t>
+              <a:t>Agent queries for anomaly summary mid-stream</a:t>
+            </a:r>
+          </a:p>
+          <a:p>
+            <a:pPr>
+              <a:spcAft>
+                <a:spcPts val="800"/>
+              </a:spcAft>
+              <a:defRPr sz="1800">
+                <a:solidFill>
+                  <a:srgbClr val="FFFFFF"/>
+                </a:solidFill>
+                <a:latin typeface="Calibri"/>
+              </a:defRPr>
+            </a:pPr>
+            <a:r>
+              <a:t>Cedar blocks unauthorized agents from sensitive streams</a:t>
             </a:r>
           </a:p>
         </p:txBody>
@@ -6442,7 +6813,7 @@
               </a:defRPr>
             </a:pPr>
             <a:r>
-              <a:t>Production Patterns &amp; Gotchas</a:t>
+              <a:t>Anomaly Detection Flow</a:t>
             </a:r>
           </a:p>
         </p:txBody>
@@ -6456,7 +6827,7 @@
         <p:spPr>
           <a:xfrm>
             <a:off x="914400" y="1280160"/>
-            <a:ext cx="10058400" cy="4754880"/>
+            <a:ext cx="5029200" cy="4754880"/>
           </a:xfrm>
           <a:prstGeom prst="rect">
             <a:avLst/>
@@ -6481,7 +6852,7 @@
               </a:defRPr>
             </a:pPr>
             <a:r>
-              <a:t>1. Backpressure: bounded queues, drop slow subscribers</a:t>
+              <a:t>Rolling window of last 100 events maintained server-side</a:t>
             </a:r>
           </a:p>
           <a:p>
@@ -6497,7 +6868,7 @@
               </a:defRPr>
             </a:pPr>
             <a:r>
-              <a:t>2. Hybrid protocol: streaming AND on-demand on same WebSocket</a:t>
+              <a:t>Error rate &gt; 30% triggers anomaly alert</a:t>
             </a:r>
           </a:p>
           <a:p>
@@ -6513,43 +6884,35 @@
               </a:defRPr>
             </a:pPr>
             <a:r>
-              <a:t>3. Kafka consumer groups: same = load balance, different = fan-out</a:t>
-            </a:r>
-          </a:p>
-          <a:p>
-            <a:pPr>
-              <a:spcAft>
-                <a:spcPts val="800"/>
-              </a:spcAft>
-              <a:defRPr sz="1800">
-                <a:solidFill>
-                  <a:srgbClr val="FFFFFF"/>
-                </a:solidFill>
-                <a:latin typeface="Calibri"/>
-              </a:defRPr>
-            </a:pPr>
-            <a:r>
-              <a:t>4. Reconnection: exponential backoff + context snapshot</a:t>
-            </a:r>
-          </a:p>
-          <a:p>
-            <a:pPr>
-              <a:spcAft>
-                <a:spcPts val="800"/>
-              </a:spcAft>
-              <a:defRPr sz="1800">
-                <a:solidFill>
-                  <a:srgbClr val="FFFFFF"/>
-                </a:solidFill>
-                <a:latin typeface="Calibri"/>
-              </a:defRPr>
-            </a:pPr>
-            <a:r>
-              <a:t>5. Be selective: stream errors &amp; anomalies, batch normal metrics</a:t>
-            </a:r>
-          </a:p>
-        </p:txBody>
-      </p:sp>
+              <a:t>Agent maps error patterns to fix suggestions automatically</a:t>
+            </a:r>
+          </a:p>
+        </p:txBody>
+      </p:sp>
+      <p:pic>
+        <p:nvPicPr>
+          <p:cNvPr id="4" name="Picture 3" descr="image.png"/>
+          <p:cNvPicPr>
+            <a:picLocks noChangeAspect="1"/>
+          </p:cNvPicPr>
+          <p:nvPr/>
+        </p:nvPicPr>
+        <p:blipFill>
+          <a:blip r:embed="rId3"/>
+          <a:stretch>
+            <a:fillRect/>
+          </a:stretch>
+        </p:blipFill>
+        <p:spPr>
+          <a:xfrm>
+            <a:off x="6217920" y="1280160"/>
+            <a:ext cx="5486400" cy="4572000"/>
+          </a:xfrm>
+          <a:prstGeom prst="rect">
+            <a:avLst/>
+          </a:prstGeom>
+        </p:spPr>
+      </p:pic>
     </p:spTree>
   </p:cSld>
   <p:clrMapOvr>

</xml_diff>